<commit_message>
Review and fix lecture slide content
</commit_message>
<xml_diff>
--- a/50_슬라이드/SLIDES_Day2.pptx
+++ b/50_슬라이드/SLIDES_Day2.pptx
@@ -562,7 +562,8 @@
           <a:p>
             <a:r>
               <a:rPr lang="en-US" dirty="0"/>
-              <a:t>Day 2 표지. 준비물: 어제 만든 ZEDU##_ORDER(주문 20건), ZEDU##_S_LIST. 오늘의 결승선: 선택화면+JOIN+금액+ALV를 갖춘 ZEDU##_LIST 완성 — 내일 toy project의 몸통.</a:t>
+              <a:t>출처: 11_교재_Day2.md; 01_커리큘럼.md; 30_강사가이드.md; 96_슬라이드_기획안.md.
+Day 2 표지. 준비물: 어제 만든 ZEDU##_ORDER(주문 20건), ZEDU##_S_LIST. 오늘의 결승선: 선택화면+JOIN+금액+ALV를 갖춘 ZEDU##_LIST 완성 — 내일 toy project의 몸통.</a:t>
             </a:r>
             <a:endParaRPr lang="en-US" dirty="0"/>
           </a:p>
@@ -650,7 +651,8 @@
           <a:p>
             <a:r>
               <a:rPr lang="en-US" dirty="0"/>
-              <a:t>순회하며 CLEAR·APPEND 방향만 봐 준다. 정답은 부록 A(비노출). 빠른 학생은 D09(총수량 누적).</a:t>
+              <a:t>출처: 11_교재_Day2.md &gt; U09; 20_퀴즈집.md &gt; U09; 30_강사가이드.md &gt; U09.
+순회하며 CLEAR·APPEND 방향만 봐 준다. 정답은 부록 A(비노출). 빠른 학생은 D09(총수량 누적).</a:t>
             </a:r>
             <a:endParaRPr lang="en-US" dirty="0"/>
           </a:p>
@@ -826,7 +828,8 @@
           <a:p>
             <a:r>
               <a:rPr lang="en-US" dirty="0"/>
-              <a:t>예상 질문 — Q. READ TABLE은 왜 SELECT가 아닌가? A. 이미 메모리에 있는 내부 테이블을 읽기 때문. DB 접근은 Open SQL SELECT. Q. sy-subrc는 항상 0/4? A. 명령마다 의미·값이 다르다.</a:t>
+              <a:t>출처: 11_교재_Day2.md &gt; U10; 20_퀴즈집.md &gt; U10; 30_강사가이드.md &gt; U10.
+예상 질문 — Q. READ TABLE은 왜 SELECT가 아닌가? A. 이미 메모리에 있는 내부 테이블을 읽기 때문. DB 접근은 Open SQL SELECT. Q. sy-subrc는 항상 0/4? A. 명령마다 의미·값이 다르다.</a:t>
             </a:r>
             <a:endParaRPr lang="en-US" dirty="0"/>
           </a:p>
@@ -914,7 +917,8 @@
           <a:p>
             <a:r>
               <a:rPr lang="en-US" dirty="0"/>
-              <a:t>READ 직후 sy-subrc/sy-tabix를 칠판에 표시. 다른 문장을 한 줄 실행해 시스템 필드가 덮이는 모습을 보여준다.</a:t>
+              <a:t>출처: 11_교재_Day2.md &gt; U10; 20_퀴즈집.md &gt; U10; 30_강사가이드.md &gt; U10.
+READ 직후 sy-subrc/sy-tabix를 칠판에 표시. 다른 문장을 한 줄 실행해 시스템 필드가 덮이는 모습을 보여준다.</a:t>
             </a:r>
             <a:endParaRPr lang="en-US" dirty="0"/>
           </a:p>
@@ -1002,7 +1006,8 @@
           <a:p>
             <a:r>
               <a:rPr lang="en-US" dirty="0"/>
-              <a:t>MODIFY 전에 워크에어리어 값을 바꾸지 않는 실수가 잦다. SORT 후 인덱스가 바뀐다는 점을 놓치는 것도. 내부 테이블 DELETE는 DB를 바꾸지 않음(색 구분).</a:t>
+              <a:t>출처: 11_교재_Day2.md &gt; U10; 20_퀴즈집.md &gt; U10; 30_강사가이드.md &gt; U10.
+MODIFY 전에 워크에어리어 값을 바꾸지 않는 실수가 잦다. SORT 후 인덱스가 바뀐다는 점을 놓치는 것도. 내부 테이블 DELETE는 DB를 바꾸지 않음(색 구분).</a:t>
             </a:r>
             <a:endParaRPr lang="en-US" dirty="0"/>
           </a:p>
@@ -1090,7 +1095,8 @@
           <a:p>
             <a:r>
               <a:rPr lang="en-US" dirty="0"/>
-              <a:t>93 검토에서 확정된 교육 포인트(퀴즈집 D10). 삭제 건수는 sy-tabix가 아니라 명시 변수(gv_deleted)에 받아 출력. WRITE에 gv_before - gv_after 같은 수식 직접 사용 금지.</a:t>
+              <a:t>출처: 11_교재_Day2.md &gt; U10; 20_퀴즈집.md &gt; U10; 30_강사가이드.md &gt; U10.
+93 검토에서 확정된 교육 포인트(퀴즈집 D10). 삭제 건수는 sy-tabix가 아니라 명시 변수(gv_deleted)에 받아 출력. WRITE에 gv_before - gv_after 같은 수식 직접 사용 금지.</a:t>
             </a:r>
             <a:endParaRPr lang="en-US" dirty="0"/>
           </a:p>
@@ -1178,7 +1184,8 @@
           <a:p>
             <a:r>
               <a:rPr lang="en-US" dirty="0"/>
-              <a:t>표 4가지는 강사가이드 U10 '자주 막힘'.</a:t>
+              <a:t>출처: 11_교재_Day2.md &gt; U10; 20_퀴즈집.md &gt; U10; 30_강사가이드.md &gt; U10.
+표 4가지는 강사가이드 U10 '자주 막힘'.</a:t>
             </a:r>
             <a:endParaRPr lang="en-US" dirty="0"/>
           </a:p>
@@ -1266,7 +1273,8 @@
           <a:p>
             <a:r>
               <a:rPr lang="en-US" dirty="0"/>
-              <a:t>gt[...]가 없는 행이면 덤프라는 점을 강조 — line_exists와 짝. 오늘 실습은 classic.</a:t>
+              <a:t>출처: 11_교재_Day2.md &gt; U10; 20_퀴즈집.md &gt; U10; 30_강사가이드.md &gt; U10.
+gt[...]가 없는 행이면 덤프라는 점을 강조 — line_exists와 짝. 오늘 실습은 classic.</a:t>
             </a:r>
             <a:endParaRPr lang="en-US" dirty="0"/>
           </a:p>
@@ -1354,7 +1362,8 @@
           <a:p>
             <a:r>
               <a:rPr lang="en-US" dirty="0"/>
-              <a:t>정답 비노출. TODO 3은 D10 규칙 확인 지점. 빠른 학생은 D10.</a:t>
+              <a:t>출처: 11_교재_Day2.md &gt; U10; 20_퀴즈집.md &gt; U10; 30_강사가이드.md &gt; U10.
+정답 비노출. TODO 3은 D10 규칙 확인 지점. 빠른 학생은 D10.</a:t>
             </a:r>
             <a:endParaRPr lang="en-US" dirty="0"/>
           </a:p>
@@ -1530,7 +1539,8 @@
           <a:p>
             <a:r>
               <a:rPr lang="en-US" dirty="0"/>
-              <a:t>R2는 지각자 버퍼 겸용. 준비물(주문 20건·S_LIST)이 없는 학생은 R2 시간에 즉시 복구. 오늘 결승선(ZEDU##_LIST)을 먼저 각인시킨다.</a:t>
+              <a:t>출처: 11_교재_Day2.md; 01_커리큘럼.md; 30_강사가이드.md; 96_슬라이드_기획안.md.
+R2는 지각자 버퍼 겸용. 준비물(주문 20건·S_LIST)이 없는 학생은 R2 시간에 즉시 복구. 오늘 결승선(ZEDU##_LIST)을 먼저 각인시킨다.</a:t>
             </a:r>
             <a:endParaRPr lang="en-US" dirty="0"/>
           </a:p>
@@ -1618,7 +1628,8 @@
           <a:p>
             <a:r>
               <a:rPr lang="en-US" dirty="0"/>
-              <a:t>예상 질문 — Q. SELECT SINGLE에 키가 아닌 조건? A. 문법 오류는 아닐 수 있으나 어떤 한 건이 선택될지 불명확. 고유 키 조건을 우선. INTO 대상 타입 불일치가 자주 막힘.</a:t>
+              <a:t>출처: 11_교재_Day2.md &gt; U11; 20_퀴즈집.md &gt; U11; 30_강사가이드.md &gt; U11.
+예상 질문 — Q. SELECT SINGLE에 키가 아닌 조건? A. 문법 오류는 아닐 수 있으나 어떤 한 건이 선택될지 불명확. 고유 키 조건을 우선. INTO 대상 타입 불일치가 자주 막힘.</a:t>
             </a:r>
             <a:endParaRPr lang="en-US" dirty="0"/>
           </a:p>
@@ -1706,7 +1717,8 @@
           <a:p>
             <a:r>
               <a:rPr lang="en-US" dirty="0"/>
-              <a:t>자주 막힘: 문자열 ID의 길이·0 개수 오타. SELECT 후 다른 문장을 실행한 뒤 sy-subrc 확인.</a:t>
+              <a:t>출처: 11_교재_Day2.md &gt; U11; 20_퀴즈집.md &gt; U11; 30_강사가이드.md &gt; U11.
+자주 막힘: 문자열 ID의 길이·0 개수 오타. SELECT 후 다른 문장을 실행한 뒤 sy-subrc 확인.</a:t>
             </a:r>
             <a:endParaRPr lang="en-US" dirty="0"/>
           </a:p>
@@ -1794,7 +1806,8 @@
           <a:p>
             <a:r>
               <a:rPr lang="en-US" dirty="0"/>
-              <a:t>ENDSELECT는 읽기용. 강조: 신규 코드는 집합 조회 우선.</a:t>
+              <a:t>출처: 11_교재_Day2.md &gt; U11; 20_퀴즈집.md &gt; U11; 30_강사가이드.md &gt; U11.
+ENDSELECT는 읽기용. 강조: 신규 코드는 집합 조회 우선.</a:t>
             </a:r>
             <a:endParaRPr lang="en-US" dirty="0"/>
           </a:p>
@@ -1882,7 +1895,8 @@
           <a:p>
             <a:r>
               <a:rPr lang="en-US" dirty="0"/>
-              <a:t>콤마/@/인라인 3대 표식. classic과 결과는 같다.</a:t>
+              <a:t>출처: 11_교재_Day2.md &gt; U11; 20_퀴즈집.md &gt; U11; 30_강사가이드.md &gt; U11.
+콤마/@/인라인 3대 표식. classic과 결과는 같다.</a:t>
             </a:r>
             <a:endParaRPr lang="en-US" dirty="0"/>
           </a:p>
@@ -1970,7 +1984,8 @@
           <a:p>
             <a:r>
               <a:rPr lang="en-US" dirty="0"/>
-              <a:t>점심 후 Q11 스켈레톤을 바로 실행하게 하고 TODO 1부터 해결. 오전 개념 재강의 없음(강사가이드).</a:t>
+              <a:t>출처: 11_교재_Day2.md; 01_커리큘럼.md; 30_강사가이드.md; 96_슬라이드_기획안.md.
+점심 후 Q11 스켈레톤을 바로 실행하게 하고 TODO 1부터 해결. 오전 개념 재강의 없음(강사가이드).</a:t>
             </a:r>
             <a:endParaRPr lang="en-US" dirty="0"/>
           </a:p>
@@ -2058,7 +2073,8 @@
           <a:p>
             <a:r>
               <a:rPr lang="en-US" dirty="0"/>
-              <a:t>정답 비노출. sy-subrc 분기가 핵심. 빠른 학생은 D11.</a:t>
+              <a:t>출처: 11_교재_Day2.md &gt; U11; 20_퀴즈집.md &gt; U11; 30_강사가이드.md &gt; U11.
+정답 비노출. sy-subrc 분기가 핵심. 빠른 학생은 D11.</a:t>
             </a:r>
             <a:endParaRPr lang="en-US" dirty="0"/>
           </a:p>
@@ -2234,7 +2250,8 @@
           <a:p>
             <a:r>
               <a:rPr lang="en-US" dirty="0"/>
-              <a:t>예상 질문 — Q. INNER JOIN에서 마스터가 없으면 주문이 나오나? A. 나오지 않음. 한쪽이 없어도 보여야 하면 LEFT OUTER JOIN 검토. JOIN 결과 행 수가 줄면 마스터 누락 가능성.</a:t>
+              <a:t>출처: 11_교재_Day2.md &gt; U12; 20_퀴즈집.md &gt; U12; 30_강사가이드.md &gt; U12.
+예상 질문 — Q. INNER JOIN에서 마스터가 없으면 주문이 나오나? A. 나오지 않음. 한쪽이 없어도 보여야 하면 LEFT OUTER JOIN 검토. JOIN 결과 행 수가 줄면 마스터 누락 가능성.</a:t>
             </a:r>
             <a:endParaRPr lang="en-US" dirty="0"/>
           </a:p>
@@ -2322,7 +2339,8 @@
           <a:p>
             <a:r>
               <a:rPr lang="en-US" dirty="0"/>
-              <a:t>별칭을 표의 색과 맞춘다. 같은 필드명을 별칭 없이 쓰는 것, CORRESPONDING인데 결과 구조 필드명이 다른 것이 자주 막힘.</a:t>
+              <a:t>출처: 11_교재_Day2.md &gt; U12; 20_퀴즈집.md &gt; U12; 30_강사가이드.md &gt; U12.
+별칭을 표의 색과 맞춘다. 같은 필드명을 별칭 없이 쓰는 것, CORRESPONDING인데 결과 구조 필드명이 다른 것이 자주 막힘.</a:t>
             </a:r>
             <a:endParaRPr lang="en-US" dirty="0"/>
           </a:p>
@@ -2410,7 +2428,8 @@
           <a:p>
             <a:r>
               <a:rPr lang="en-US" dirty="0"/>
-              <a:t>집계하지 않은 필드를 GROUP BY에 빠뜨리는 것, UP TO와 ORDER BY 위치 오타가 자주 막힘.</a:t>
+              <a:t>출처: 11_교재_Day2.md &gt; U12; 20_퀴즈집.md &gt; U12; 30_강사가이드.md &gt; U12.
+집계하지 않은 필드를 GROUP BY에 빠뜨리는 것, UP TO와 ORDER BY 위치 오타가 자주 막힘.</a:t>
             </a:r>
             <a:endParaRPr lang="en-US" dirty="0"/>
           </a:p>
@@ -2586,7 +2605,8 @@
           <a:p>
             <a:r>
               <a:rPr lang="en-US" dirty="0"/>
-              <a:t>퀴즈집 D12 확정 패턴. ORDER BY에 집계함수를 직접 쓰지 않고 SELECT 목록의 AS 별칭으로 정렬. 동률의 표시 순서는 DB에 따라 달라질 수 있어 보조 정렬 기준을 추가.</a:t>
+              <a:t>출처: 11_교재_Day2.md &gt; U12; 20_퀴즈집.md &gt; U12; 30_강사가이드.md &gt; U12.
+퀴즈집 D12 확정 패턴. ORDER BY에 집계함수를 직접 쓰지 않고 SELECT 목록의 AS 별칭으로 정렬. 동률의 표시 순서는 DB에 따라 달라질 수 있어 보조 정렬 기준을 추가.</a:t>
             </a:r>
             <a:endParaRPr lang="en-US" dirty="0"/>
           </a:p>
@@ -2674,7 +2694,8 @@
           <a:p>
             <a:r>
               <a:rPr lang="en-US" dirty="0"/>
-              <a:t>FOR ALL ENTRIES는 빈 원본 테이블의 위험만 소개하고 실습하지 않는다. 신문법 세계에서는 JOIN/CDS로 대체 추세.</a:t>
+              <a:t>출처: 11_교재_Day2.md &gt; U12; 20_퀴즈집.md &gt; U12; 30_강사가이드.md &gt; U12.
+FOR ALL ENTRIES는 빈 원본 테이블의 위험만 소개하고 실습하지 않는다. 신문법 세계에서는 JOIN/CDS로 대체 추세.</a:t>
             </a:r>
             <a:endParaRPr lang="en-US" dirty="0"/>
           </a:p>
@@ -2762,7 +2783,8 @@
           <a:p>
             <a:r>
               <a:rPr lang="en-US" dirty="0"/>
-              <a:t>classic JOIN과 결과 동일. 표식만 다르다.</a:t>
+              <a:t>출처: 11_교재_Day2.md &gt; U12; 20_퀴즈집.md &gt; U12; 30_강사가이드.md &gt; U12.
+classic JOIN과 결과 동일. 표식만 다르다.</a:t>
             </a:r>
             <a:endParaRPr lang="en-US" dirty="0"/>
           </a:p>
@@ -2850,7 +2872,8 @@
           <a:p>
             <a:r>
               <a:rPr lang="en-US" dirty="0"/>
-              <a:t>정답 비노출. D12는 방금 배운 별칭 정렬을 응용.</a:t>
+              <a:t>출처: 11_교재_Day2.md &gt; U12; 20_퀴즈집.md &gt; U12; 30_강사가이드.md &gt; U12.
+정답 비노출. D12는 방금 배운 별칭 정렬을 응용.</a:t>
             </a:r>
             <a:endParaRPr lang="en-US" dirty="0"/>
           </a:p>
@@ -3026,7 +3049,8 @@
           <a:p>
             <a:r>
               <a:rPr lang="en-US" dirty="0"/>
-              <a:t>SELECT-OPTIONS를 화면 요소이자 내부 테이블로 동시에 설명. 예상 질문 — Q. SELECT-OPTIONS가 비면 왜 전체? A. 제한 조건이 없는 것으로 해석. PARAMETERS 초기값과 동작이 다르다.</a:t>
+              <a:t>출처: 11_교재_Day2.md &gt; U13; 20_퀴즈집.md &gt; U13; 30_강사가이드.md &gt; U13.
+SELECT-OPTIONS를 화면 요소이자 내부 테이블로 동시에 설명. 예상 질문 — Q. SELECT-OPTIONS가 비면 왜 전체? A. 제한 조건이 없는 것으로 해석. PARAMETERS 초기값과 동작이 다르다.</a:t>
             </a:r>
             <a:endParaRPr lang="en-US" dirty="0"/>
           </a:p>
@@ -3114,7 +3138,8 @@
           <a:p>
             <a:r>
               <a:rPr lang="en-US" dirty="0"/>
-              <a:t>FOR 뒤에 타입명을 직접 쓰는 실수(참조 필드가 필요). SELECT-OPTIONS에 = 사용(IN을 써야). 빈 PARAMETERS를 WHERE에 바로 넣어 0건 조회.</a:t>
+              <a:t>출처: 11_교재_Day2.md &gt; U13; 20_퀴즈집.md &gt; U13; 30_강사가이드.md &gt; U13.
+FOR 뒤에 타입명을 직접 쓰는 실수(참조 필드가 필요). SELECT-OPTIONS에 = 사용(IN을 써야). 빈 PARAMETERS를 WHERE에 바로 넣어 0건 조회.</a:t>
             </a:r>
             <a:endParaRPr lang="en-US" dirty="0"/>
           </a:p>
@@ -3202,7 +3227,8 @@
           <a:p>
             <a:r>
               <a:rPr lang="en-US" dirty="0"/>
-              <a:t>선택 텍스트를 붙이기 전·후를 비교. Selection Texts 저장 후 프로그램 활성화 누락이 자주 막힘. F4 도메인 고정값은 어제 U06 도메인 설계의 보상.</a:t>
+              <a:t>출처: 11_교재_Day2.md &gt; U13; 20_퀴즈집.md &gt; U13; 30_강사가이드.md &gt; U13.
+선택 텍스트를 붙이기 전·후를 비교. Selection Texts 저장 후 프로그램 활성화 누락이 자주 막힘. F4 도메인 고정값은 어제 U06 도메인 설계의 보상.</a:t>
             </a:r>
             <a:endParaRPr lang="en-US" dirty="0"/>
           </a:p>
@@ -3290,7 +3316,8 @@
           <a:p>
             <a:r>
               <a:rPr lang="en-US" dirty="0"/>
-              <a:t>표 4가지는 강사가이드 U13 '자주 막힘'.</a:t>
+              <a:t>출처: 11_교재_Day2.md &gt; U13; 20_퀴즈집.md &gt; U13; 30_강사가이드.md &gt; U13.
+표 4가지는 강사가이드 U13 '자주 막힘'.</a:t>
             </a:r>
             <a:endParaRPr lang="en-US" dirty="0"/>
           </a:p>
@@ -3378,7 +3405,8 @@
           <a:p>
             <a:r>
               <a:rPr lang="en-US" dirty="0"/>
-              <a:t>정답 비노출. TODO 3은 화면 조작(복수 선택). 빠른 학생은 D13.</a:t>
+              <a:t>출처: 11_교재_Day2.md &gt; U13; 20_퀴즈집.md &gt; U13; 30_강사가이드.md &gt; U13.
+정답 비노출. TODO 3은 화면 조작(복수 선택). 빠른 학생은 D13.</a:t>
             </a:r>
             <a:endParaRPr lang="en-US" dirty="0"/>
           </a:p>
@@ -3554,7 +3582,8 @@
           <a:p>
             <a:r>
               <a:rPr lang="en-US" dirty="0"/>
-              <a:t>U09~U13이 종합실습의 재료임을 각인. U14(언제)·U15(어떻게)가 남았다.</a:t>
+              <a:t>출처: 11_교재_Day2.md &gt; U13; 20_퀴즈집.md &gt; U13; 30_강사가이드.md &gt; U13.
+U09~U13이 종합실습의 재료임을 각인. U14(언제)·U15(어떻게)가 남았다.</a:t>
             </a:r>
             <a:endParaRPr lang="en-US" dirty="0"/>
           </a:p>
@@ -3730,7 +3759,8 @@
           <a:p>
             <a:r>
               <a:rPr lang="en-US" dirty="0"/>
-              <a:t>화면에 이 순서를 계속 표시. 예상 질문 — Q. 이벤트 순서는 소스에 쓴 순서인가? A. 리포트 런타임 이벤트 순서가 정한다. 읽기 쉽도록 통상 실행 순서대로 배치.</a:t>
+              <a:t>출처: 11_교재_Day2.md &gt; U14; 20_퀴즈집.md &gt; U14; 30_강사가이드.md &gt; U14.
+화면에 이 순서를 계속 표시. 예상 질문 — Q. 이벤트 순서는 소스에 쓴 순서인가? A. 리포트 런타임 이벤트 순서가 정한다. 읽기 쉽도록 통상 실행 순서대로 배치.</a:t>
             </a:r>
             <a:endParaRPr lang="en-US" dirty="0"/>
           </a:p>
@@ -3818,7 +3848,8 @@
           <a:p>
             <a:r>
               <a:rPr lang="en-US" dirty="0"/>
-              <a:t>SELECT-OPTIONS 기본 행을 채우고 APPEND 누락이 자주 막힘. INITIALIZATION은 선택화면 표시 전 1회.</a:t>
+              <a:t>출처: 11_교재_Day2.md &gt; U14; 20_퀴즈집.md &gt; U14; 30_강사가이드.md &gt; U14.
+SELECT-OPTIONS 기본 행을 채우고 APPEND 누락이 자주 막힘. INITIALIZATION은 선택화면 표시 전 1회.</a:t>
             </a:r>
             <a:endParaRPr lang="en-US" dirty="0"/>
           </a:p>
@@ -3906,7 +3937,8 @@
           <a:p>
             <a:r>
               <a:rPr lang="en-US" dirty="0"/>
-              <a:t>E 메시지를 START-OF-SELECTION에서 쓰고 선택화면 복귀를 기대하는 실수가 잦다. 위치별 행동 차이는 Day 3 U18/버튼 로직의 기초.</a:t>
+              <a:t>출처: 11_교재_Day2.md &gt; U14; 20_퀴즈집.md &gt; U14; 30_강사가이드.md &gt; U14.
+E 메시지를 START-OF-SELECTION에서 쓰고 선택화면 복귀를 기대하는 실수가 잦다. 위치별 행동 차이는 Day 3 U18/버튼 로직의 기초.</a:t>
             </a:r>
             <a:endParaRPr lang="en-US" dirty="0"/>
           </a:p>
@@ -3994,7 +4026,8 @@
           <a:p>
             <a:r>
               <a:rPr lang="en-US" dirty="0"/>
-              <a:t>표 3가지는 강사가이드 U14 '자주 막힘'.</a:t>
+              <a:t>출처: 11_교재_Day2.md &gt; U14; 20_퀴즈집.md &gt; U14; 30_강사가이드.md &gt; U14.
+표 3가지는 강사가이드 U14 '자주 막힘'.</a:t>
             </a:r>
             <a:endParaRPr lang="en-US" dirty="0"/>
           </a:p>
@@ -4082,7 +4115,8 @@
           <a:p>
             <a:r>
               <a:rPr lang="en-US" dirty="0"/>
-              <a:t>정답 비노출. 검증이 선택화면에 머물러야 하므로 AT SELECTION-SCREEN. 빠른 학생은 D14.</a:t>
+              <a:t>출처: 11_교재_Day2.md &gt; U14; 20_퀴즈집.md &gt; U14; 30_강사가이드.md &gt; U14.
+정답 비노출. 검증이 선택화면에 머물러야 하므로 AT SELECTION-SCREEN. 빠른 학생은 D14.</a:t>
             </a:r>
             <a:endParaRPr lang="en-US" dirty="0"/>
           </a:p>
@@ -4258,7 +4292,8 @@
           <a:p>
             <a:r>
               <a:rPr lang="en-US" dirty="0"/>
-              <a:t>ALV가 콜백(FORM 호출) 방식이라 FORM/PERFORM을 먼저 5분. 파라미터 전달은 내일.</a:t>
+              <a:t>출처: 11_교재_Day2.md &gt; U15; 20_퀴즈집.md &gt; U15; 30_강사가이드.md &gt; U15.
+ALV가 콜백(FORM 호출) 방식이라 FORM/PERFORM을 먼저 5분. 파라미터 전달은 내일.</a:t>
             </a:r>
             <a:endParaRPr lang="en-US" dirty="0"/>
           </a:p>
@@ -4346,7 +4381,8 @@
           <a:p>
             <a:r>
               <a:rPr lang="en-US" dirty="0"/>
-              <a:t>예상 질문 — Q. REUSE ALV는 오래된 기술 아닌가? A. 클래식 코드에서 여전히 많이 만나며 콜백 구조 학습에 좋다. 신규는 프로젝트 기준에 따라 SALV/OO ALV/Fiori 검토.</a:t>
+              <a:t>출처: 11_교재_Day2.md &gt; U15; 20_퀴즈집.md &gt; U15; 30_강사가이드.md &gt; U15.
+예상 질문 — Q. REUSE ALV는 오래된 기술 아닌가? A. 클래식 코드에서 여전히 많이 만나며 콜백 구조 학습에 좋다. 신규는 프로젝트 기준에 따라 SALV/OO ALV/Fiori 검토.</a:t>
             </a:r>
             <a:endParaRPr lang="en-US" dirty="0"/>
           </a:p>
@@ -4434,7 +4470,8 @@
           <a:p>
             <a:r>
               <a:rPr lang="en-US" dirty="0"/>
-              <a:t>예상 질문 — Q. 내부 테이블과 DB 테이블 차이? A. 내부 테이블은 실행 중 메모리에만, DB 테이블은 데이터베이스에 지속 저장. 헤더라인은 혼란스러워 이 과정은 명시적으로 분리한다.</a:t>
+              <a:t>출처: 11_교재_Day2.md &gt; U09; 20_퀴즈집.md &gt; U09; 30_강사가이드.md &gt; U09.
+예상 질문 — Q. 내부 테이블과 DB 테이블 차이? A. 내부 테이블은 실행 중 메모리에만, DB 테이블은 데이터베이스에 지속 저장. 헤더라인은 혼란스러워 이 과정은 명시적으로 분리한다.</a:t>
             </a:r>
             <a:endParaRPr lang="en-US" dirty="0"/>
           </a:p>
@@ -4522,7 +4559,8 @@
           <a:p>
             <a:r>
               <a:rPr lang="en-US" dirty="0"/>
-              <a:t>금액은 DB에 없는 계산 필드. LOOP + MODIFY TRANSPORTING로 채운다. MODIFY 누락 주의. gt_list는 어제 만든 ZEDU##_S_LIST 스트럭처.</a:t>
+              <a:t>출처: 11_교재_Day2.md &gt; U15; 20_퀴즈집.md &gt; U15; 30_강사가이드.md &gt; U15.
+금액은 DB에 없는 계산 필드. LOOP + MODIFY TRANSPORTING로 채운다. MODIFY 누락 주의. gt_list는 어제 만든 ZEDU##_S_LIST 스트럭처.</a:t>
             </a:r>
             <a:endParaRPr lang="en-US" dirty="0"/>
           </a:p>
@@ -4610,7 +4648,8 @@
           <a:p>
             <a:r>
               <a:rPr lang="en-US" dirty="0"/>
-              <a:t>TYPE-POOLS: slis. 누락, DDIC 스트럭처 이름의 학생 번호 오타, ALV 호출 오류 sy-subrc 미확인이 자주 막힘.</a:t>
+              <a:t>출처: 11_교재_Day2.md &gt; U15; 20_퀴즈집.md &gt; U15; 30_강사가이드.md &gt; U15.
+TYPE-POOLS: slis. 누락, DDIC 스트럭처 이름의 학생 번호 오타, ALV 호출 오류 sy-subrc 미확인이 자주 막힘.</a:t>
             </a:r>
             <a:endParaRPr lang="en-US" dirty="0"/>
           </a:p>
@@ -4698,7 +4737,8 @@
           <a:p>
             <a:r>
               <a:rPr lang="en-US" dirty="0"/>
-              <a:t>i_structure_name이 DDIC 라벨을 필드 카탈로그로 바꿔준다. 필드 카탈로그를 직접 만들지 않는 이유: 첫 과정 분량 보호 + DDIC 재사용 효과. do_sum 같은 확장은 퀴즈집.</a:t>
+              <a:t>출처: 11_교재_Day2.md &gt; U15; 20_퀴즈집.md &gt; U15; 30_강사가이드.md &gt; U15.
+i_structure_name이 DDIC 라벨을 필드 카탈로그로 바꿔준다. 필드 카탈로그를 직접 만들지 않는 이유: 첫 과정 분량 보호 + DDIC 재사용 효과. do_sum 같은 확장은 퀴즈집.</a:t>
             </a:r>
             <a:endParaRPr lang="en-US" dirty="0"/>
           </a:p>
@@ -4786,7 +4826,8 @@
           <a:p>
             <a:r>
               <a:rPr lang="en-US" dirty="0"/>
-              <a:t>한글 컬럼은 어제 DE 라벨의 결과. 합계는 AMOUNT에. i_structure_name 제거 시 오류를 직접 보여준다.</a:t>
+              <a:t>출처: 11_교재_Day2.md &gt; U15; 20_퀴즈집.md &gt; U15; 30_강사가이드.md &gt; U15.
+한글 컬럼은 어제 DE 라벨의 결과. 합계는 AMOUNT에. i_structure_name 제거 시 오류를 직접 보여준다.</a:t>
             </a:r>
             <a:endParaRPr lang="en-US" dirty="0"/>
           </a:p>
@@ -4874,7 +4915,8 @@
           <a:p>
             <a:r>
               <a:rPr lang="en-US" dirty="0"/>
-              <a:t>SALV는 보조 박스이며 TRY/CATCH를 포함해야 안전. OO ABAP을 배우면 첫 실전 상대.</a:t>
+              <a:t>출처: 11_교재_Day2.md &gt; U15; 20_퀴즈집.md &gt; U15; 30_강사가이드.md &gt; U15.
+SALV는 보조 박스이며 TRY/CATCH를 포함해야 안전. OO ABAP을 배우면 첫 실전 상대.</a:t>
             </a:r>
             <a:endParaRPr lang="en-US" dirty="0"/>
           </a:p>
@@ -4962,7 +5004,8 @@
           <a:p>
             <a:r>
               <a:rPr lang="en-US" dirty="0"/>
-              <a:t>정답 비노출. 정렬은 호출 전 SORT. 빠른 학생은 D15(do_sum).</a:t>
+              <a:t>출처: 11_교재_Day2.md &gt; U15; 20_퀴즈집.md &gt; U15; 30_강사가이드.md &gt; U15.
+정답 비노출. 정렬은 호출 전 SORT. 빠른 학생은 D15(do_sum).</a:t>
             </a:r>
             <a:endParaRPr lang="en-US" dirty="0"/>
           </a:p>
@@ -5050,7 +5093,8 @@
           <a:p>
             <a:r>
               <a:rPr lang="en-US" dirty="0"/>
-              <a:t>오늘의 결승선. 미완료 상태로 퇴실시키지 않는다. 필요시 완성 FORM get_data 조각을 제공하고 학생이 직접 붙여 활성화.</a:t>
+              <a:t>출처: 11_교재_Day2.md; 01_커리큘럼.md; 30_강사가이드.md; 96_슬라이드_기획안.md.
+오늘의 결승선. 미완료 상태로 퇴실시키지 않는다. 필요시 완성 FORM get_data 조각을 제공하고 학생이 직접 붙여 활성화.</a:t>
             </a:r>
             <a:endParaRPr lang="en-US" dirty="0"/>
           </a:p>
@@ -5138,7 +5182,8 @@
           <a:p>
             <a:r>
               <a:rPr lang="en-US" dirty="0"/>
-              <a:t>TODO는 get_data 세 곳뿐. 각 TODO가 오늘 배운 유닛과 1:1. 완성 코드는 부록 A(비노출).</a:t>
+              <a:t>출처: 11_교재_Day2.md &gt; 종합실습 ②; 30_강사가이드.md &gt; 종합실습②.
+TODO는 get_data 세 곳뿐. 각 TODO가 오늘 배운 유닛과 1:1. 완성 코드는 부록 A(비노출).</a:t>
             </a:r>
             <a:endParaRPr lang="en-US" dirty="0"/>
           </a:p>
@@ -5226,7 +5271,8 @@
           <a:p>
             <a:r>
               <a:rPr lang="en-US" dirty="0"/>
-              <a:t>체크포인트는 강사가이드 종합실습② 표. 종합실습②는 '절대 줄이지 않을 구간'. 시점마다 순회 확인.</a:t>
+              <a:t>출처: 11_교재_Day2.md &gt; 종합실습 ②; 30_강사가이드.md &gt; 종합실습②.
+체크포인트는 강사가이드 종합실습② 표. 종합실습②는 '절대 줄이지 않을 구간'. 시점마다 순회 확인.</a:t>
             </a:r>
             <a:endParaRPr lang="en-US" dirty="0"/>
           </a:p>
@@ -5314,7 +5360,8 @@
           <a:p>
             <a:r>
               <a:rPr lang="en-US" dirty="0"/>
-              <a:t>복구 우선순위는 강사가이드. 미완료 학생에겐 완성 FORM get_data 조각 제공 후 직접 붙여 활성화. 이 프로그램은 Day 3에 LIST→U19→MAIN으로 복사.</a:t>
+              <a:t>출처: 11_교재_Day2.md &gt; 종합실습 ②; 30_강사가이드.md &gt; 종합실습②.
+복구 우선순위는 강사가이드. 미완료 학생에겐 완성 FORM get_data 조각 제공 후 직접 붙여 활성화. 이 프로그램은 Day 3에 LIST→U19→MAIN으로 복사.</a:t>
             </a:r>
             <a:endParaRPr lang="en-US" dirty="0"/>
           </a:p>
@@ -5402,7 +5449,8 @@
           <a:p>
             <a:r>
               <a:rPr lang="en-US" dirty="0"/>
-              <a:t>APPEND는 워크에어리어의 '현재 값'을 복사한다는 점을 강조. sy-tabix를 데이터의 주문번호로 오해하는 것이 자주 막힘.</a:t>
+              <a:t>출처: 11_교재_Day2.md &gt; U09; 20_퀴즈집.md &gt; U09; 30_강사가이드.md &gt; U09.
+APPEND는 워크에어리어의 '현재 값'을 복사한다는 점을 강조. sy-tabix를 데이터의 주문번호로 오해하는 것이 자주 막힘.</a:t>
             </a:r>
             <a:endParaRPr lang="en-US" dirty="0"/>
           </a:p>
@@ -5490,7 +5538,8 @@
           <a:p>
             <a:r>
               <a:rPr lang="en-US" dirty="0"/>
-              <a:t>체크리스트 미달(특히 ZEDU##_LIST 미완성)은 Day 3 아침 09:00 전 개별 복구. 종합실습②는 Day 3 프로그램 복사 체인의 출발점.</a:t>
+              <a:t>출처: 11_교재_Day2.md; 01_커리큘럼.md; 30_강사가이드.md; 96_슬라이드_기획안.md.
+체크리스트 미달(특히 ZEDU##_LIST 미완성)은 Day 3 아침 09:00 전 개별 복구. 종합실습②는 Day 3 프로그램 복사 체인의 출발점.</a:t>
             </a:r>
             <a:endParaRPr lang="en-US" dirty="0"/>
           </a:p>
@@ -5578,7 +5627,8 @@
           <a:p>
             <a:r>
               <a:rPr lang="en-US" dirty="0"/>
-              <a:t>내일 예고: FM → CRUD → 버튼 → 완성. 오늘의 ZEDU##_LIST가 ZEDU##_MAIN의 몸통.</a:t>
+              <a:t>출처: 11_교재_Day2.md; 01_커리큘럼.md; 30_강사가이드.md; 96_슬라이드_기획안.md.
+내일 예고: FM → CRUD → 버튼 → 완성. 오늘의 ZEDU##_LIST가 ZEDU##_MAIN의 몸통.</a:t>
             </a:r>
             <a:endParaRPr lang="en-US" dirty="0"/>
           </a:p>
@@ -5666,7 +5716,8 @@
           <a:p>
             <a:r>
               <a:rPr lang="en-US" dirty="0"/>
-              <a:t>각 덩어리 입력 후 바로 활성화. CLEAR 하나를 일부러 지워 잔여값이 섞이는 것을 관찰(💡 교재). 자주 막힘: TYPE TABLE OF를 워크에어리어에 사용, APPEND 방향 반대.</a:t>
+              <a:t>출처: 11_교재_Day2.md &gt; U09; 20_퀴즈집.md &gt; U09; 30_강사가이드.md &gt; U09.
+각 덩어리 입력 후 바로 활성화. CLEAR 하나를 일부러 지워 잔여값이 섞이는 것을 관찰(💡 교재). 자주 막힘: TYPE TABLE OF를 워크에어리어에 사용, APPEND 방향 반대.</a:t>
             </a:r>
             <a:endParaRPr lang="en-US" dirty="0"/>
           </a:p>
@@ -5754,7 +5805,8 @@
           <a:p>
             <a:r>
               <a:rPr lang="en-US" dirty="0"/>
-              <a:t>표의 4가지는 강사가이드 U09 '자주 막힘'. 순회 시 이 순서로 본다.</a:t>
+              <a:t>출처: 11_교재_Day2.md &gt; U09; 20_퀴즈집.md &gt; U09; 30_강사가이드.md &gt; U09.
+표의 4가지는 강사가이드 U09 '자주 막힘'. 순회 시 이 순서로 본다.</a:t>
             </a:r>
             <a:endParaRPr lang="en-US" dirty="0"/>
           </a:p>
@@ -5842,7 +5894,8 @@
           <a:p>
             <a:r>
               <a:rPr lang="en-US" dirty="0"/>
-              <a:t>시간이 밀리면 이 슬라이드는 건너뛴다(교재에 있음). 신문법 질문이 길어지면 '보조·확장 영역'임을 안내.</a:t>
+              <a:t>출처: 11_교재_Day2.md &gt; U09; 20_퀴즈집.md &gt; U09; 30_강사가이드.md &gt; U09.
+시간이 밀리면 이 슬라이드는 건너뛴다(교재에 있음). 신문법 질문이 길어지면 '보조·확장 영역'임을 안내.</a:t>
             </a:r>
             <a:endParaRPr lang="en-US" dirty="0"/>
           </a:p>
@@ -28478,7 +28531,7 @@
                 <a:ea typeface="Malgun Gothic" pitchFamily="34" charset="-122"/>
                 <a:cs typeface="Malgun Gothic" pitchFamily="34" charset="-120"/>
               </a:rPr>
-              <a:t>선택화면 실행 — SELECT-OPTIONS 복수선택 팝업</a:t>
+              <a:t>주문번호 복수선택 팝업 — 포함/제외 탭</a:t>
             </a:r>
             <a:endParaRPr lang="en-US" sz="1300" dirty="0"/>
           </a:p>
@@ -28495,7 +28548,7 @@
                 <a:ea typeface="Malgun Gothic" pitchFamily="34" charset="-122"/>
                 <a:cs typeface="Malgun Gothic" pitchFamily="34" charset="-120"/>
               </a:rPr>
-              <a:t>(주문번호 화살표 → 포함/제외 탭)</a:t>
+              <a:t>선택 텍스트 라벨(상태·주문일·주문번호)</a:t>
             </a:r>
             <a:endParaRPr lang="en-US" sz="1300" dirty="0"/>
           </a:p>

</xml_diff>

<commit_message>
Standardize slide labels and timing cues
</commit_message>
<xml_diff>
--- a/50_슬라이드/SLIDES_Day2.pptx
+++ b/50_슬라이드/SLIDES_Day2.pptx
@@ -563,7 +563,7 @@
             <a:r>
               <a:rPr lang="en-US" dirty="0"/>
               <a:t>출처: 11_교재_Day2.md; 01_커리큘럼.md; 30_강사가이드.md; 96_슬라이드_기획안.md.
-Day 2 표지. 준비물: 어제 만든 ZEDU##_ORDER(주문 20건), ZEDU##_S_LIST. 오늘의 결승선: 선택화면+JOIN+금액+ALV를 갖춘 ZEDU##_LIST 완성 — 내일 toy project의 몸통.</a:t>
+Day 2 표지. 준비물: 어제 만든 ZEDU##_ORDER(주문 20건), ZEDU##_S_LIST. 오늘의 결승선: 선택화면+JOIN+금액+ALV를 갖춘 ZEDU##_LIST 완성 — 내일 Toy Project의 몸통.</a:t>
             </a:r>
             <a:endParaRPr lang="en-US" dirty="0"/>
           </a:p>
@@ -7387,7 +7387,7 @@
                 <a:ea typeface="Malgun Gothic" pitchFamily="34" charset="-122"/>
                 <a:cs typeface="Malgun Gothic" pitchFamily="34" charset="-120"/>
               </a:rPr>
-              <a:t>퀴즈집 U09-D</a:t>
+              <a:t>퀴즈집 D09</a:t>
             </a:r>
             <a:endParaRPr lang="en-US" sz="1200" dirty="0"/>
           </a:p>
@@ -7407,7 +7407,7 @@
                 <a:ea typeface="Malgun Gothic" pitchFamily="34" charset="-122"/>
                 <a:cs typeface="Malgun Gothic" pitchFamily="34" charset="-120"/>
               </a:rPr>
-              <a:t>(어려웠다면 U09-E) · 정답은 부록 A</a:t>
+              <a:t>(어려웠다면 E09) · 정답은 부록 A</a:t>
             </a:r>
             <a:endParaRPr lang="en-US" sz="1200" dirty="0"/>
           </a:p>
@@ -13488,7 +13488,7 @@
                 <a:ea typeface="Malgun Gothic" pitchFamily="34" charset="-122"/>
                 <a:cs typeface="Malgun Gothic" pitchFamily="34" charset="-120"/>
               </a:rPr>
-              <a:t>퀴즈집 U10-D (정렬 후 취소 제거)</a:t>
+              <a:t>퀴즈집 D10 (정렬 후 취소 제거)</a:t>
             </a:r>
             <a:endParaRPr lang="en-US" sz="1250" dirty="0"/>
           </a:p>
@@ -13508,7 +13508,7 @@
                 <a:ea typeface="Malgun Gothic" pitchFamily="34" charset="-122"/>
                 <a:cs typeface="Malgun Gothic" pitchFamily="34" charset="-120"/>
               </a:rPr>
-              <a:t>어려웠다면 U10-E</a:t>
+              <a:t>어려웠다면 E10</a:t>
             </a:r>
             <a:endParaRPr lang="en-US" sz="1250" dirty="0"/>
           </a:p>
@@ -16069,7 +16069,7 @@
                 <a:ea typeface="Malgun Gothic" pitchFamily="34" charset="-122"/>
                 <a:cs typeface="Malgun Gothic" pitchFamily="34" charset="-120"/>
               </a:rPr>
-              <a:t>내일 toy project의 몸통이 됩니다.</a:t>
+              <a:t>내일 Toy Project의 몸통이 됩니다.</a:t>
             </a:r>
             <a:endParaRPr lang="en-US" sz="1300" dirty="0"/>
           </a:p>
@@ -19960,7 +19960,7 @@
                 <a:ea typeface="Malgun Gothic" pitchFamily="34" charset="-122"/>
                 <a:cs typeface="Malgun Gothic" pitchFamily="34" charset="-120"/>
               </a:rPr>
-              <a:t>퀴즈집 U11-D</a:t>
+              <a:t>퀴즈집 D11</a:t>
             </a:r>
             <a:endParaRPr lang="en-US" sz="1250" dirty="0"/>
           </a:p>
@@ -19980,7 +19980,7 @@
                 <a:ea typeface="Malgun Gothic" pitchFamily="34" charset="-122"/>
                 <a:cs typeface="Malgun Gothic" pitchFamily="34" charset="-120"/>
               </a:rPr>
-              <a:t>(어려웠다면 U11-E)</a:t>
+              <a:t>(어려웠다면 E11)</a:t>
             </a:r>
             <a:endParaRPr lang="en-US" sz="1250" dirty="0"/>
           </a:p>
@@ -25901,7 +25901,7 @@
                 <a:ea typeface="Malgun Gothic" pitchFamily="34" charset="-122"/>
                 <a:cs typeface="Malgun Gothic" pitchFamily="34" charset="-120"/>
               </a:rPr>
-              <a:t>퀴즈집 U12-D</a:t>
+              <a:t>퀴즈집 D12</a:t>
             </a:r>
             <a:endParaRPr lang="en-US" sz="1200" dirty="0"/>
           </a:p>
@@ -25961,7 +25961,7 @@
                 <a:ea typeface="Malgun Gothic" pitchFamily="34" charset="-122"/>
                 <a:cs typeface="Malgun Gothic" pitchFamily="34" charset="-120"/>
               </a:rPr>
-              <a:t>어려웠다면 U12-E</a:t>
+              <a:t>어려웠다면 E12</a:t>
             </a:r>
             <a:endParaRPr lang="en-US" sz="1200" dirty="0"/>
           </a:p>
@@ -30091,7 +30091,7 @@
                 <a:ea typeface="Malgun Gothic" pitchFamily="34" charset="-122"/>
                 <a:cs typeface="Malgun Gothic" pitchFamily="34" charset="-120"/>
               </a:rPr>
-              <a:t>퀴즈집 U13-D</a:t>
+              <a:t>퀴즈집 D13</a:t>
             </a:r>
             <a:endParaRPr lang="en-US" sz="1250" dirty="0"/>
           </a:p>
@@ -30131,7 +30131,7 @@
                 <a:ea typeface="Malgun Gothic" pitchFamily="34" charset="-122"/>
                 <a:cs typeface="Malgun Gothic" pitchFamily="34" charset="-120"/>
               </a:rPr>
-              <a:t>어려웠다면 U13-E</a:t>
+              <a:t>어려웠다면 E13</a:t>
             </a:r>
             <a:endParaRPr lang="en-US" sz="1250" dirty="0"/>
           </a:p>
@@ -36137,7 +36137,7 @@
                 <a:ea typeface="Malgun Gothic" pitchFamily="34" charset="-122"/>
                 <a:cs typeface="Malgun Gothic" pitchFamily="34" charset="-120"/>
               </a:rPr>
-              <a:t>퀴즈집 U14-D (최근 30일 기본 범위) · 어려웠다면 U14-E · 정답은 부록 A — 지금은 보지 않기!</a:t>
+              <a:t>퀴즈집 D14 (최근 30일 기본 범위) · 어려웠다면 E14 · 정답은 부록 A — 지금은 보지 않기!</a:t>
             </a:r>
             <a:endParaRPr lang="en-US" sz="1300" dirty="0"/>
           </a:p>
@@ -42990,7 +42990,7 @@
                 <a:ea typeface="Malgun Gothic" pitchFamily="34" charset="-122"/>
                 <a:cs typeface="Malgun Gothic" pitchFamily="34" charset="-120"/>
               </a:rPr>
-              <a:t>퀴즈집 U15-D</a:t>
+              <a:t>퀴즈집 D15</a:t>
             </a:r>
             <a:endParaRPr lang="en-US" sz="1250" dirty="0"/>
           </a:p>
@@ -43030,7 +43030,7 @@
                 <a:ea typeface="Malgun Gothic" pitchFamily="34" charset="-122"/>
                 <a:cs typeface="Malgun Gothic" pitchFamily="34" charset="-120"/>
               </a:rPr>
-              <a:t>어려웠다면 U15-E</a:t>
+              <a:t>어려웠다면 E15</a:t>
             </a:r>
             <a:endParaRPr lang="en-US" sz="1250" dirty="0"/>
           </a:p>
@@ -43369,7 +43369,7 @@
                 <a:ea typeface="Malgun Gothic" pitchFamily="34" charset="-122"/>
                 <a:cs typeface="Malgun Gothic" pitchFamily="34" charset="-120"/>
               </a:rPr>
-              <a:t>이 프로그램이 내일 toy project의 몸통이 됩니다 — 반드시 완성하고 퇴근!</a:t>
+              <a:t>이 프로그램이 내일 Toy Project의 몸통이 됩니다 — 반드시 완성하고 퇴근!</a:t>
             </a:r>
             <a:endParaRPr lang="en-US" sz="1700" dirty="0"/>
           </a:p>

</xml_diff>